<commit_message>
added todo form me
</commit_message>
<xml_diff>
--- a/FPGA Implementation/Handshake/V0.4.4/Images of code1.pptx
+++ b/FPGA Implementation/Handshake/V0.4.4/Images of code1.pptx
@@ -4530,20 +4530,20 @@
 </file>
 
 <file path=customXml/item2.xml><?xml version="1.0" encoding="utf-8"?>
-<p:properties xmlns:p="http://schemas.microsoft.com/office/2006/metadata/properties" xmlns:xsi="http://www.w3.org/2001/XMLSchema-instance" xmlns:pc="http://schemas.microsoft.com/office/infopath/2007/PartnerControls">
-  <documentManagement>
-    <_activity xmlns="d3afe3c7-f7c7-4289-8ec7-fcbbb8b750c6" xsi:nil="true"/>
-  </documentManagement>
-</p:properties>
-</file>
-
-<file path=customXml/item3.xml><?xml version="1.0" encoding="utf-8"?>
 <?mso-contentType ?>
 <FormTemplates xmlns="http://schemas.microsoft.com/sharepoint/v3/contenttype/forms">
   <Display>DocumentLibraryForm</Display>
   <Edit>DocumentLibraryForm</Edit>
   <New>DocumentLibraryForm</New>
 </FormTemplates>
+</file>
+
+<file path=customXml/item3.xml><?xml version="1.0" encoding="utf-8"?>
+<p:properties xmlns:p="http://schemas.microsoft.com/office/2006/metadata/properties" xmlns:xsi="http://www.w3.org/2001/XMLSchema-instance" xmlns:pc="http://schemas.microsoft.com/office/infopath/2007/PartnerControls">
+  <documentManagement>
+    <_activity xmlns="d3afe3c7-f7c7-4289-8ec7-fcbbb8b750c6" xsi:nil="true"/>
+  </documentManagement>
+</p:properties>
 </file>
 
 <file path=customXml/itemProps1.xml><?xml version="1.0" encoding="utf-8"?>
@@ -4566,6 +4566,14 @@
 </file>
 
 <file path=customXml/itemProps2.xml><?xml version="1.0" encoding="utf-8"?>
+<ds:datastoreItem xmlns:ds="http://schemas.openxmlformats.org/officeDocument/2006/customXml" ds:itemID="{D9C45F11-969A-418C-A26A-264100A49ADB}">
+  <ds:schemaRefs>
+    <ds:schemaRef ds:uri="http://schemas.microsoft.com/sharepoint/v3/contenttype/forms"/>
+  </ds:schemaRefs>
+</ds:datastoreItem>
+</file>
+
+<file path=customXml/itemProps3.xml><?xml version="1.0" encoding="utf-8"?>
 <ds:datastoreItem xmlns:ds="http://schemas.openxmlformats.org/officeDocument/2006/customXml" ds:itemID="{FEFA0585-9349-44C3-81BF-B9D8E8CD4A3A}">
   <ds:schemaRefs>
     <ds:schemaRef ds:uri="http://schemas.openxmlformats.org/package/2006/metadata/core-properties"/>
@@ -4580,12 +4588,4 @@
     <ds:schemaRef ds:uri="http://schemas.microsoft.com/office/2006/metadata/properties"/>
   </ds:schemaRefs>
 </ds:datastoreItem>
-</file>
-
-<file path=customXml/itemProps3.xml><?xml version="1.0" encoding="utf-8"?>
-<ds:datastoreItem xmlns:ds="http://schemas.openxmlformats.org/officeDocument/2006/customXml" ds:itemID="{D9C45F11-969A-418C-A26A-264100A49ADB}">
-  <ds:schemaRefs>
-    <ds:schemaRef ds:uri="http://schemas.microsoft.com/sharepoint/v3/contenttype/forms"/>
-  </ds:schemaRefs>
-</ds:datastoreItem>
 </file>
</xml_diff>